<commit_message>
docs(apresentacao): roteiro sem menção a tempo
O slide 2 deixa de mostrar tempos: o título vira "Roteiro: quatro
integrantes, quatro blocos" e saem as barras de 5 minutos e a linha do
total previsto, no .pptx e no HTML. O tempo previsto de cada slide
continua nas notas de quem apresenta, para o ensaio. Pendências e guia
do grupo explicam que o roteiro é montado pelo bloco de cada slide.
</commit_message>
<xml_diff>
--- a/docs/apresentacao/apresentacao-projeto1.pptx
+++ b/docs/apresentacao/apresentacao-projeto1.pptx
@@ -16182,7 +16182,7 @@
                 <a:ea typeface="Calibri" pitchFamily="34" charset="-122"/>
                 <a:cs typeface="Calibri" pitchFamily="34" charset="-120"/>
               </a:rPr>
-              <a:t>Roteiro: quatro integrantes, tempos iguais</a:t>
+              <a:t>Roteiro: quatro integrantes, quatro blocos</a:t>
             </a:r>
             <a:endParaRPr lang="en-US" sz="3200" dirty="0"/>
           </a:p>
@@ -16197,7 +16197,7 @@
         <p:spPr>
           <a:xfrm>
             <a:off x="548640" y="1600200"/>
-            <a:ext cx="2651760" cy="4251960"/>
+            <a:ext cx="2651760" cy="4389120"/>
           </a:xfrm>
           <a:prstGeom prst="roundRect">
             <a:avLst>
@@ -16372,8 +16372,8 @@
         </p:nvSpPr>
         <p:spPr>
           <a:xfrm>
-            <a:off x="777240" y="3566160"/>
-            <a:ext cx="2240280" cy="1463040"/>
+            <a:off x="777240" y="3611880"/>
+            <a:ext cx="2240280" cy="2194560"/>
           </a:xfrm>
           <a:prstGeom prst="rect">
             <a:avLst/>
@@ -16389,7 +16389,7 @@
               <a:buNone/>
             </a:pPr>
             <a:r>
-              <a:rPr lang="en-US" sz="1400" dirty="0">
+              <a:rPr lang="en-US" sz="1600" dirty="0">
                 <a:solidFill>
                   <a:srgbClr val="1F2937"/>
                 </a:solidFill>
@@ -16399,59 +16399,20 @@
               </a:rPr>
               <a:t>Motivação: o problema, as perguntas do gestor, a escolha de São Paulo e os cinco assuntos de interesse.</a:t>
             </a:r>
-            <a:endParaRPr lang="en-US" sz="1400" dirty="0"/>
+            <a:endParaRPr lang="en-US" sz="1600" dirty="0"/>
           </a:p>
         </p:txBody>
       </p:sp>
       <p:sp>
         <p:nvSpPr>
-          <p:cNvPr id="11" name="anim:1:252"/>
-          <p:cNvSpPr txBox="1"/>
-          <p:nvPr/>
-        </p:nvSpPr>
-        <p:spPr>
-          <a:xfrm>
-            <a:off x="777240" y="5074920"/>
-            <a:ext cx="2240280" cy="594360"/>
-          </a:xfrm>
-          <a:prstGeom prst="rect">
-            <a:avLst/>
-          </a:prstGeom>
-          <a:noFill/>
-          <a:ln/>
-        </p:spPr>
-        <p:txBody>
-          <a:bodyPr wrap="square" lIns="0" tIns="0" rIns="0" bIns="0" rtlCol="0" anchor="t"/>
-          <a:lstStyle/>
-          <a:p>
-            <a:pPr algn="l" indent="0" marL="0">
-              <a:buNone/>
-            </a:pPr>
-            <a:r>
-              <a:rPr lang="en-US" sz="3000" b="1" dirty="0">
-                <a:solidFill>
-                  <a:srgbClr val="2E5EAA"/>
-                </a:solidFill>
-                <a:latin typeface="Calibri" pitchFamily="34" charset="0"/>
-                <a:ea typeface="Calibri" pitchFamily="34" charset="-122"/>
-                <a:cs typeface="Calibri" pitchFamily="34" charset="-120"/>
-              </a:rPr>
-              <a:t>5 min</a:t>
-            </a:r>
-            <a:endParaRPr lang="en-US" sz="3000" dirty="0"/>
-          </a:p>
-        </p:txBody>
-      </p:sp>
-      <p:sp>
-        <p:nvSpPr>
-          <p:cNvPr id="12" name="anim:2:253"/>
+          <p:cNvPr id="11" name="anim:2:252"/>
           <p:cNvSpPr/>
           <p:nvPr/>
         </p:nvSpPr>
         <p:spPr>
           <a:xfrm>
             <a:off x="3360420" y="1600200"/>
-            <a:ext cx="2651760" cy="4251960"/>
+            <a:ext cx="2651760" cy="4389120"/>
           </a:xfrm>
           <a:prstGeom prst="roundRect">
             <a:avLst>
@@ -16478,7 +16439,7 @@
       </p:sp>
       <p:sp>
         <p:nvSpPr>
-          <p:cNvPr id="13" name="anim:2:254"/>
+          <p:cNvPr id="12" name="anim:2:253"/>
           <p:cNvSpPr/>
           <p:nvPr/>
         </p:nvSpPr>
@@ -16503,7 +16464,7 @@
       </p:sp>
       <p:sp>
         <p:nvSpPr>
-          <p:cNvPr id="14" name="anim:2:255"/>
+          <p:cNvPr id="13" name="anim:2:254"/>
           <p:cNvSpPr txBox="1"/>
           <p:nvPr/>
         </p:nvSpPr>
@@ -16542,7 +16503,7 @@
       </p:sp>
       <p:sp>
         <p:nvSpPr>
-          <p:cNvPr id="15" name="anim:2:256"/>
+          <p:cNvPr id="14" name="anim:2:255"/>
           <p:cNvSpPr txBox="1"/>
           <p:nvPr/>
         </p:nvSpPr>
@@ -16581,7 +16542,7 @@
       </p:sp>
       <p:sp>
         <p:nvSpPr>
-          <p:cNvPr id="16" name="anim:2:257"/>
+          <p:cNvPr id="15" name="anim:2:256"/>
           <p:cNvSpPr txBox="1"/>
           <p:nvPr/>
         </p:nvSpPr>
@@ -16620,14 +16581,14 @@
       </p:sp>
       <p:sp>
         <p:nvSpPr>
-          <p:cNvPr id="17" name="anim:2:258"/>
+          <p:cNvPr id="16" name="anim:2:257"/>
           <p:cNvSpPr txBox="1"/>
           <p:nvPr/>
         </p:nvSpPr>
         <p:spPr>
           <a:xfrm>
-            <a:off x="3589020" y="3566160"/>
-            <a:ext cx="2240280" cy="1463040"/>
+            <a:off x="3589020" y="3611880"/>
+            <a:ext cx="2240280" cy="2194560"/>
           </a:xfrm>
           <a:prstGeom prst="rect">
             <a:avLst/>
@@ -16643,7 +16604,7 @@
               <a:buNone/>
             </a:pPr>
             <a:r>
-              <a:rPr lang="en-US" sz="1400" dirty="0">
+              <a:rPr lang="en-US" sz="1600" dirty="0">
                 <a:solidFill>
                   <a:srgbClr val="1F2937"/>
                 </a:solidFill>
@@ -16653,59 +16614,20 @@
               </a:rPr>
               <a:t>Fontes de dados, integração, problemas nos dados, grão e aditividade e a estrela Matrícula.</a:t>
             </a:r>
-            <a:endParaRPr lang="en-US" sz="1400" dirty="0"/>
+            <a:endParaRPr lang="en-US" sz="1600" dirty="0"/>
           </a:p>
         </p:txBody>
       </p:sp>
       <p:sp>
         <p:nvSpPr>
-          <p:cNvPr id="18" name="anim:2:259"/>
-          <p:cNvSpPr txBox="1"/>
-          <p:nvPr/>
-        </p:nvSpPr>
-        <p:spPr>
-          <a:xfrm>
-            <a:off x="3589020" y="5074920"/>
-            <a:ext cx="2240280" cy="594360"/>
-          </a:xfrm>
-          <a:prstGeom prst="rect">
-            <a:avLst/>
-          </a:prstGeom>
-          <a:noFill/>
-          <a:ln/>
-        </p:spPr>
-        <p:txBody>
-          <a:bodyPr wrap="square" lIns="0" tIns="0" rIns="0" bIns="0" rtlCol="0" anchor="t"/>
-          <a:lstStyle/>
-          <a:p>
-            <a:pPr algn="l" indent="0" marL="0">
-              <a:buNone/>
-            </a:pPr>
-            <a:r>
-              <a:rPr lang="en-US" sz="3000" b="1" dirty="0">
-                <a:solidFill>
-                  <a:srgbClr val="2E5EAA"/>
-                </a:solidFill>
-                <a:latin typeface="Calibri" pitchFamily="34" charset="0"/>
-                <a:ea typeface="Calibri" pitchFamily="34" charset="-122"/>
-                <a:cs typeface="Calibri" pitchFamily="34" charset="-120"/>
-              </a:rPr>
-              <a:t>5 min</a:t>
-            </a:r>
-            <a:endParaRPr lang="en-US" sz="3000" dirty="0"/>
-          </a:p>
-        </p:txBody>
-      </p:sp>
-      <p:sp>
-        <p:nvSpPr>
-          <p:cNvPr id="19" name="anim:3:260"/>
+          <p:cNvPr id="17" name="anim:3:258"/>
           <p:cNvSpPr/>
           <p:nvPr/>
         </p:nvSpPr>
         <p:spPr>
           <a:xfrm>
             <a:off x="6172200" y="1600200"/>
-            <a:ext cx="2651760" cy="4251960"/>
+            <a:ext cx="2651760" cy="4389120"/>
           </a:xfrm>
           <a:prstGeom prst="roundRect">
             <a:avLst>
@@ -16732,7 +16654,7 @@
       </p:sp>
       <p:sp>
         <p:nvSpPr>
-          <p:cNvPr id="20" name="anim:3:261"/>
+          <p:cNvPr id="18" name="anim:3:259"/>
           <p:cNvSpPr/>
           <p:nvPr/>
         </p:nvSpPr>
@@ -16757,7 +16679,7 @@
       </p:sp>
       <p:sp>
         <p:nvSpPr>
-          <p:cNvPr id="21" name="anim:3:262"/>
+          <p:cNvPr id="19" name="anim:3:260"/>
           <p:cNvSpPr txBox="1"/>
           <p:nvPr/>
         </p:nvSpPr>
@@ -16796,7 +16718,7 @@
       </p:sp>
       <p:sp>
         <p:nvSpPr>
-          <p:cNvPr id="22" name="anim:3:263"/>
+          <p:cNvPr id="20" name="anim:3:261"/>
           <p:cNvSpPr txBox="1"/>
           <p:nvPr/>
         </p:nvSpPr>
@@ -16835,7 +16757,7 @@
       </p:sp>
       <p:sp>
         <p:nvSpPr>
-          <p:cNvPr id="23" name="anim:3:264"/>
+          <p:cNvPr id="21" name="anim:3:262"/>
           <p:cNvSpPr txBox="1"/>
           <p:nvPr/>
         </p:nvSpPr>
@@ -16874,14 +16796,14 @@
       </p:sp>
       <p:sp>
         <p:nvSpPr>
-          <p:cNvPr id="24" name="anim:3:265"/>
+          <p:cNvPr id="22" name="anim:3:263"/>
           <p:cNvSpPr txBox="1"/>
           <p:nvPr/>
         </p:nvSpPr>
         <p:spPr>
           <a:xfrm>
-            <a:off x="6400800" y="3566160"/>
-            <a:ext cx="2240280" cy="1463040"/>
+            <a:off x="6400800" y="3611880"/>
+            <a:ext cx="2240280" cy="2194560"/>
           </a:xfrm>
           <a:prstGeom prst="rect">
             <a:avLst/>
@@ -16897,7 +16819,7 @@
               <a:buNone/>
             </a:pPr>
             <a:r>
-              <a:rPr lang="en-US" sz="1400" dirty="0">
+              <a:rPr lang="en-US" sz="1600" dirty="0">
                 <a:solidFill>
                   <a:srgbClr val="1F2937"/>
                 </a:solidFill>
@@ -16907,59 +16829,20 @@
               </a:rPr>
               <a:t>Estrelas Fila, Desfecho, Ocupação de Turma e População; constelação de fatos.</a:t>
             </a:r>
-            <a:endParaRPr lang="en-US" sz="1400" dirty="0"/>
+            <a:endParaRPr lang="en-US" sz="1600" dirty="0"/>
           </a:p>
         </p:txBody>
       </p:sp>
       <p:sp>
         <p:nvSpPr>
-          <p:cNvPr id="25" name="anim:3:266"/>
-          <p:cNvSpPr txBox="1"/>
-          <p:nvPr/>
-        </p:nvSpPr>
-        <p:spPr>
-          <a:xfrm>
-            <a:off x="6400800" y="5074920"/>
-            <a:ext cx="2240280" cy="594360"/>
-          </a:xfrm>
-          <a:prstGeom prst="rect">
-            <a:avLst/>
-          </a:prstGeom>
-          <a:noFill/>
-          <a:ln/>
-        </p:spPr>
-        <p:txBody>
-          <a:bodyPr wrap="square" lIns="0" tIns="0" rIns="0" bIns="0" rtlCol="0" anchor="t"/>
-          <a:lstStyle/>
-          <a:p>
-            <a:pPr algn="l" indent="0" marL="0">
-              <a:buNone/>
-            </a:pPr>
-            <a:r>
-              <a:rPr lang="en-US" sz="3000" b="1" dirty="0">
-                <a:solidFill>
-                  <a:srgbClr val="2E5EAA"/>
-                </a:solidFill>
-                <a:latin typeface="Calibri" pitchFamily="34" charset="0"/>
-                <a:ea typeface="Calibri" pitchFamily="34" charset="-122"/>
-                <a:cs typeface="Calibri" pitchFamily="34" charset="-120"/>
-              </a:rPr>
-              <a:t>5 min</a:t>
-            </a:r>
-            <a:endParaRPr lang="en-US" sz="3000" dirty="0"/>
-          </a:p>
-        </p:txBody>
-      </p:sp>
-      <p:sp>
-        <p:nvSpPr>
-          <p:cNvPr id="26" name="anim:4:267"/>
+          <p:cNvPr id="23" name="anim:4:264"/>
           <p:cNvSpPr/>
           <p:nvPr/>
         </p:nvSpPr>
         <p:spPr>
           <a:xfrm>
             <a:off x="8983980" y="1600200"/>
-            <a:ext cx="2651760" cy="4251960"/>
+            <a:ext cx="2651760" cy="4389120"/>
           </a:xfrm>
           <a:prstGeom prst="roundRect">
             <a:avLst>
@@ -16986,7 +16869,7 @@
       </p:sp>
       <p:sp>
         <p:nvSpPr>
-          <p:cNvPr id="27" name="anim:4:268"/>
+          <p:cNvPr id="24" name="anim:4:265"/>
           <p:cNvSpPr/>
           <p:nvPr/>
         </p:nvSpPr>
@@ -17011,7 +16894,7 @@
       </p:sp>
       <p:sp>
         <p:nvSpPr>
-          <p:cNvPr id="28" name="anim:4:269"/>
+          <p:cNvPr id="25" name="anim:4:266"/>
           <p:cNvSpPr txBox="1"/>
           <p:nvPr/>
         </p:nvSpPr>
@@ -17050,7 +16933,7 @@
       </p:sp>
       <p:sp>
         <p:nvSpPr>
-          <p:cNvPr id="29" name="anim:4:270"/>
+          <p:cNvPr id="26" name="anim:4:267"/>
           <p:cNvSpPr txBox="1"/>
           <p:nvPr/>
         </p:nvSpPr>
@@ -17089,7 +16972,7 @@
       </p:sp>
       <p:sp>
         <p:nvSpPr>
-          <p:cNvPr id="30" name="anim:4:271"/>
+          <p:cNvPr id="27" name="anim:4:268"/>
           <p:cNvSpPr txBox="1"/>
           <p:nvPr/>
         </p:nvSpPr>
@@ -17128,14 +17011,14 @@
       </p:sp>
       <p:sp>
         <p:nvSpPr>
-          <p:cNvPr id="31" name="anim:4:272"/>
+          <p:cNvPr id="28" name="anim:4:269"/>
           <p:cNvSpPr txBox="1"/>
           <p:nvPr/>
         </p:nvSpPr>
         <p:spPr>
           <a:xfrm>
-            <a:off x="9212580" y="3566160"/>
-            <a:ext cx="2240280" cy="1463040"/>
+            <a:off x="9212580" y="3611880"/>
+            <a:ext cx="2240280" cy="2194560"/>
           </a:xfrm>
           <a:prstGeom prst="rect">
             <a:avLst/>
@@ -17151,7 +17034,7 @@
               <a:buNone/>
             </a:pPr>
             <a:r>
-              <a:rPr lang="en-US" sz="1400" dirty="0">
+              <a:rPr lang="en-US" sz="1600" dirty="0">
                 <a:solidFill>
                   <a:srgbClr val="1F2937"/>
                 </a:solidFill>
@@ -17161,85 +17044,7 @@
               </a:rPr>
               <a:t>Consultas OLAP, resultados com os dados reais e decisões de projeto.</a:t>
             </a:r>
-            <a:endParaRPr lang="en-US" sz="1400" dirty="0"/>
-          </a:p>
-        </p:txBody>
-      </p:sp>
-      <p:sp>
-        <p:nvSpPr>
-          <p:cNvPr id="32" name="anim:4:273"/>
-          <p:cNvSpPr txBox="1"/>
-          <p:nvPr/>
-        </p:nvSpPr>
-        <p:spPr>
-          <a:xfrm>
-            <a:off x="9212580" y="5074920"/>
-            <a:ext cx="2240280" cy="594360"/>
-          </a:xfrm>
-          <a:prstGeom prst="rect">
-            <a:avLst/>
-          </a:prstGeom>
-          <a:noFill/>
-          <a:ln/>
-        </p:spPr>
-        <p:txBody>
-          <a:bodyPr wrap="square" lIns="0" tIns="0" rIns="0" bIns="0" rtlCol="0" anchor="t"/>
-          <a:lstStyle/>
-          <a:p>
-            <a:pPr algn="l" indent="0" marL="0">
-              <a:buNone/>
-            </a:pPr>
-            <a:r>
-              <a:rPr lang="en-US" sz="3000" b="1" dirty="0">
-                <a:solidFill>
-                  <a:srgbClr val="2E5EAA"/>
-                </a:solidFill>
-                <a:latin typeface="Calibri" pitchFamily="34" charset="0"/>
-                <a:ea typeface="Calibri" pitchFamily="34" charset="-122"/>
-                <a:cs typeface="Calibri" pitchFamily="34" charset="-120"/>
-              </a:rPr>
-              <a:t>5 min</a:t>
-            </a:r>
-            <a:endParaRPr lang="en-US" sz="3000" dirty="0"/>
-          </a:p>
-        </p:txBody>
-      </p:sp>
-      <p:sp>
-        <p:nvSpPr>
-          <p:cNvPr id="33" name="anim:5:274"/>
-          <p:cNvSpPr txBox="1"/>
-          <p:nvPr/>
-        </p:nvSpPr>
-        <p:spPr>
-          <a:xfrm>
-            <a:off x="548640" y="5989320"/>
-            <a:ext cx="11064240" cy="292608"/>
-          </a:xfrm>
-          <a:prstGeom prst="rect">
-            <a:avLst/>
-          </a:prstGeom>
-          <a:noFill/>
-          <a:ln/>
-        </p:spPr>
-        <p:txBody>
-          <a:bodyPr wrap="square" lIns="0" tIns="0" rIns="0" bIns="0" rtlCol="0" anchor="t"/>
-          <a:lstStyle/>
-          <a:p>
-            <a:pPr algn="l" indent="0" marL="0">
-              <a:buNone/>
-            </a:pPr>
-            <a:r>
-              <a:rPr lang="en-US" sz="1200" i="1" dirty="0">
-                <a:solidFill>
-                  <a:srgbClr val="566175"/>
-                </a:solidFill>
-                <a:latin typeface="Calibri" pitchFamily="34" charset="0"/>
-                <a:ea typeface="Calibri" pitchFamily="34" charset="-122"/>
-                <a:cs typeface="Calibri" pitchFamily="34" charset="-120"/>
-              </a:rPr>
-              <a:t>Total previsto: 20 minutos, sem contar as perguntas. Com outro limite de tempo, a divisão continua em quatro partes iguais.</a:t>
-            </a:r>
-            <a:endParaRPr lang="en-US" sz="1200" dirty="0"/>
+            <a:endParaRPr lang="en-US" sz="1600" dirty="0"/>
           </a:p>
         </p:txBody>
       </p:sp>
@@ -17583,7 +17388,7 @@
                         <p:par>
                           <p:cTn id="28" fill="hold">
                             <p:stCondLst>
-                              <p:cond delay="0"/>
+                              <p:cond delay="250"/>
                             </p:stCondLst>
                             <p:childTnLst>
                               <p:par>
@@ -17847,7 +17652,7 @@
                         <p:par>
                           <p:cTn id="52" fill="hold">
                             <p:stCondLst>
-                              <p:cond delay="250"/>
+                              <p:cond delay="500"/>
                             </p:stCondLst>
                             <p:childTnLst>
                               <p:par>
@@ -17891,7 +17696,7 @@
                         <p:par>
                           <p:cTn id="56" fill="hold">
                             <p:stCondLst>
-                              <p:cond delay="250"/>
+                              <p:cond delay="500"/>
                             </p:stCondLst>
                             <p:childTnLst>
                               <p:par>
@@ -18111,7 +17916,7 @@
                         <p:par>
                           <p:cTn id="76" fill="hold">
                             <p:stCondLst>
-                              <p:cond delay="500"/>
+                              <p:cond delay="750"/>
                             </p:stCondLst>
                             <p:childTnLst>
                               <p:par>
@@ -18155,7 +17960,7 @@
                         <p:par>
                           <p:cTn id="80" fill="hold">
                             <p:stCondLst>
-                              <p:cond delay="500"/>
+                              <p:cond delay="750"/>
                             </p:stCondLst>
                             <p:childTnLst>
                               <p:par>
@@ -18199,7 +18004,7 @@
                         <p:par>
                           <p:cTn id="84" fill="hold">
                             <p:stCondLst>
-                              <p:cond delay="500"/>
+                              <p:cond delay="750"/>
                             </p:stCondLst>
                             <p:childTnLst>
                               <p:par>
@@ -18363,226 +18168,6 @@
                                         <p:cTn id="99" dur="400"/>
                                         <p:tgtEl>
                                           <p:spTgt spid="28"/>
-                                        </p:tgtEl>
-                                      </p:cBhvr>
-                                    </p:animEffect>
-                                  </p:childTnLst>
-                                </p:cTn>
-                              </p:par>
-                            </p:childTnLst>
-                          </p:cTn>
-                        </p:par>
-                        <p:par>
-                          <p:cTn id="100" fill="hold">
-                            <p:stCondLst>
-                              <p:cond delay="750"/>
-                            </p:stCondLst>
-                            <p:childTnLst>
-                              <p:par>
-                                <p:cTn id="101" presetID="10" presetClass="entr" presetSubtype="0" fill="hold" grpId="0" nodeType="withEffect">
-                                  <p:stCondLst>
-                                    <p:cond delay="0"/>
-                                  </p:stCondLst>
-                                  <p:childTnLst>
-                                    <p:set>
-                                      <p:cBhvr>
-                                        <p:cTn id="102" dur="1" fill="hold">
-                                          <p:stCondLst>
-                                            <p:cond delay="0"/>
-                                          </p:stCondLst>
-                                        </p:cTn>
-                                        <p:tgtEl>
-                                          <p:spTgt spid="29"/>
-                                        </p:tgtEl>
-                                        <p:attrNameLst>
-                                          <p:attrName>style.visibility</p:attrName>
-                                        </p:attrNameLst>
-                                      </p:cBhvr>
-                                      <p:to>
-                                        <p:strVal val="visible"/>
-                                      </p:to>
-                                    </p:set>
-                                    <p:animEffect transition="in" filter="fade">
-                                      <p:cBhvr>
-                                        <p:cTn id="103" dur="400"/>
-                                        <p:tgtEl>
-                                          <p:spTgt spid="29"/>
-                                        </p:tgtEl>
-                                      </p:cBhvr>
-                                    </p:animEffect>
-                                  </p:childTnLst>
-                                </p:cTn>
-                              </p:par>
-                            </p:childTnLst>
-                          </p:cTn>
-                        </p:par>
-                        <p:par>
-                          <p:cTn id="104" fill="hold">
-                            <p:stCondLst>
-                              <p:cond delay="750"/>
-                            </p:stCondLst>
-                            <p:childTnLst>
-                              <p:par>
-                                <p:cTn id="105" presetID="10" presetClass="entr" presetSubtype="0" fill="hold" grpId="0" nodeType="withEffect">
-                                  <p:stCondLst>
-                                    <p:cond delay="0"/>
-                                  </p:stCondLst>
-                                  <p:childTnLst>
-                                    <p:set>
-                                      <p:cBhvr>
-                                        <p:cTn id="106" dur="1" fill="hold">
-                                          <p:stCondLst>
-                                            <p:cond delay="0"/>
-                                          </p:stCondLst>
-                                        </p:cTn>
-                                        <p:tgtEl>
-                                          <p:spTgt spid="30"/>
-                                        </p:tgtEl>
-                                        <p:attrNameLst>
-                                          <p:attrName>style.visibility</p:attrName>
-                                        </p:attrNameLst>
-                                      </p:cBhvr>
-                                      <p:to>
-                                        <p:strVal val="visible"/>
-                                      </p:to>
-                                    </p:set>
-                                    <p:animEffect transition="in" filter="fade">
-                                      <p:cBhvr>
-                                        <p:cTn id="107" dur="400"/>
-                                        <p:tgtEl>
-                                          <p:spTgt spid="30"/>
-                                        </p:tgtEl>
-                                      </p:cBhvr>
-                                    </p:animEffect>
-                                  </p:childTnLst>
-                                </p:cTn>
-                              </p:par>
-                            </p:childTnLst>
-                          </p:cTn>
-                        </p:par>
-                        <p:par>
-                          <p:cTn id="108" fill="hold">
-                            <p:stCondLst>
-                              <p:cond delay="750"/>
-                            </p:stCondLst>
-                            <p:childTnLst>
-                              <p:par>
-                                <p:cTn id="109" presetID="10" presetClass="entr" presetSubtype="0" fill="hold" grpId="0" nodeType="withEffect">
-                                  <p:stCondLst>
-                                    <p:cond delay="0"/>
-                                  </p:stCondLst>
-                                  <p:childTnLst>
-                                    <p:set>
-                                      <p:cBhvr>
-                                        <p:cTn id="110" dur="1" fill="hold">
-                                          <p:stCondLst>
-                                            <p:cond delay="0"/>
-                                          </p:stCondLst>
-                                        </p:cTn>
-                                        <p:tgtEl>
-                                          <p:spTgt spid="31"/>
-                                        </p:tgtEl>
-                                        <p:attrNameLst>
-                                          <p:attrName>style.visibility</p:attrName>
-                                        </p:attrNameLst>
-                                      </p:cBhvr>
-                                      <p:to>
-                                        <p:strVal val="visible"/>
-                                      </p:to>
-                                    </p:set>
-                                    <p:animEffect transition="in" filter="fade">
-                                      <p:cBhvr>
-                                        <p:cTn id="111" dur="400"/>
-                                        <p:tgtEl>
-                                          <p:spTgt spid="31"/>
-                                        </p:tgtEl>
-                                      </p:cBhvr>
-                                    </p:animEffect>
-                                  </p:childTnLst>
-                                </p:cTn>
-                              </p:par>
-                            </p:childTnLst>
-                          </p:cTn>
-                        </p:par>
-                        <p:par>
-                          <p:cTn id="112" fill="hold">
-                            <p:stCondLst>
-                              <p:cond delay="750"/>
-                            </p:stCondLst>
-                            <p:childTnLst>
-                              <p:par>
-                                <p:cTn id="113" presetID="10" presetClass="entr" presetSubtype="0" fill="hold" grpId="0" nodeType="withEffect">
-                                  <p:stCondLst>
-                                    <p:cond delay="0"/>
-                                  </p:stCondLst>
-                                  <p:childTnLst>
-                                    <p:set>
-                                      <p:cBhvr>
-                                        <p:cTn id="114" dur="1" fill="hold">
-                                          <p:stCondLst>
-                                            <p:cond delay="0"/>
-                                          </p:stCondLst>
-                                        </p:cTn>
-                                        <p:tgtEl>
-                                          <p:spTgt spid="32"/>
-                                        </p:tgtEl>
-                                        <p:attrNameLst>
-                                          <p:attrName>style.visibility</p:attrName>
-                                        </p:attrNameLst>
-                                      </p:cBhvr>
-                                      <p:to>
-                                        <p:strVal val="visible"/>
-                                      </p:to>
-                                    </p:set>
-                                    <p:animEffect transition="in" filter="fade">
-                                      <p:cBhvr>
-                                        <p:cTn id="115" dur="400"/>
-                                        <p:tgtEl>
-                                          <p:spTgt spid="32"/>
-                                        </p:tgtEl>
-                                      </p:cBhvr>
-                                    </p:animEffect>
-                                  </p:childTnLst>
-                                </p:cTn>
-                              </p:par>
-                            </p:childTnLst>
-                          </p:cTn>
-                        </p:par>
-                        <p:par>
-                          <p:cTn id="116" fill="hold">
-                            <p:stCondLst>
-                              <p:cond delay="1000"/>
-                            </p:stCondLst>
-                            <p:childTnLst>
-                              <p:par>
-                                <p:cTn id="117" presetID="10" presetClass="entr" presetSubtype="0" fill="hold" grpId="0" nodeType="withEffect">
-                                  <p:stCondLst>
-                                    <p:cond delay="0"/>
-                                  </p:stCondLst>
-                                  <p:childTnLst>
-                                    <p:set>
-                                      <p:cBhvr>
-                                        <p:cTn id="118" dur="1" fill="hold">
-                                          <p:stCondLst>
-                                            <p:cond delay="0"/>
-                                          </p:stCondLst>
-                                        </p:cTn>
-                                        <p:tgtEl>
-                                          <p:spTgt spid="33"/>
-                                        </p:tgtEl>
-                                        <p:attrNameLst>
-                                          <p:attrName>style.visibility</p:attrName>
-                                        </p:attrNameLst>
-                                      </p:cBhvr>
-                                      <p:to>
-                                        <p:strVal val="visible"/>
-                                      </p:to>
-                                    </p:set>
-                                    <p:animEffect transition="in" filter="fade">
-                                      <p:cBhvr>
-                                        <p:cTn id="119" dur="400"/>
-                                        <p:tgtEl>
-                                          <p:spTgt spid="33"/>
                                         </p:tgtEl>
                                       </p:cBhvr>
                                     </p:animEffect>
@@ -18641,11 +18226,6 @@
       <p:bldP spid="26" grpId="0" animBg="1"/>
       <p:bldP spid="27" grpId="0" animBg="1"/>
       <p:bldP spid="28" grpId="0" animBg="1"/>
-      <p:bldP spid="29" grpId="0" animBg="1"/>
-      <p:bldP spid="30" grpId="0" animBg="1"/>
-      <p:bldP spid="31" grpId="0" animBg="1"/>
-      <p:bldP spid="32" grpId="0" animBg="1"/>
-      <p:bldP spid="33" grpId="0" animBg="1"/>
     </p:bldLst>
   </p:timing>
 </p:sld>

</xml_diff>

<commit_message>
Roteiro sem tempo, dias de matrícula negativos como nulo e apresentação de 20 minutos (#7)
Slide 2 sem menção a tempo no .pptx e no HTML; dias de matrícula negativos da SME ficam nulos na carga, com teste e documentação; pendências com a data (29/10) e a duração (20 minutos).
</commit_message>
<xml_diff>
--- a/docs/apresentacao/apresentacao-projeto1.pptx
+++ b/docs/apresentacao/apresentacao-projeto1.pptx
@@ -16182,7 +16182,7 @@
                 <a:ea typeface="Calibri" pitchFamily="34" charset="-122"/>
                 <a:cs typeface="Calibri" pitchFamily="34" charset="-120"/>
               </a:rPr>
-              <a:t>Roteiro: quatro integrantes, tempos iguais</a:t>
+              <a:t>Roteiro: quatro integrantes, quatro blocos</a:t>
             </a:r>
             <a:endParaRPr lang="en-US" sz="3200" dirty="0"/>
           </a:p>
@@ -16197,7 +16197,7 @@
         <p:spPr>
           <a:xfrm>
             <a:off x="548640" y="1600200"/>
-            <a:ext cx="2651760" cy="4251960"/>
+            <a:ext cx="2651760" cy="4389120"/>
           </a:xfrm>
           <a:prstGeom prst="roundRect">
             <a:avLst>
@@ -16372,8 +16372,8 @@
         </p:nvSpPr>
         <p:spPr>
           <a:xfrm>
-            <a:off x="777240" y="3566160"/>
-            <a:ext cx="2240280" cy="1463040"/>
+            <a:off x="777240" y="3611880"/>
+            <a:ext cx="2240280" cy="2194560"/>
           </a:xfrm>
           <a:prstGeom prst="rect">
             <a:avLst/>
@@ -16389,7 +16389,7 @@
               <a:buNone/>
             </a:pPr>
             <a:r>
-              <a:rPr lang="en-US" sz="1400" dirty="0">
+              <a:rPr lang="en-US" sz="1600" dirty="0">
                 <a:solidFill>
                   <a:srgbClr val="1F2937"/>
                 </a:solidFill>
@@ -16399,59 +16399,20 @@
               </a:rPr>
               <a:t>Motivação: o problema, as perguntas do gestor, a escolha de São Paulo e os cinco assuntos de interesse.</a:t>
             </a:r>
-            <a:endParaRPr lang="en-US" sz="1400" dirty="0"/>
+            <a:endParaRPr lang="en-US" sz="1600" dirty="0"/>
           </a:p>
         </p:txBody>
       </p:sp>
       <p:sp>
         <p:nvSpPr>
-          <p:cNvPr id="11" name="anim:1:252"/>
-          <p:cNvSpPr txBox="1"/>
-          <p:nvPr/>
-        </p:nvSpPr>
-        <p:spPr>
-          <a:xfrm>
-            <a:off x="777240" y="5074920"/>
-            <a:ext cx="2240280" cy="594360"/>
-          </a:xfrm>
-          <a:prstGeom prst="rect">
-            <a:avLst/>
-          </a:prstGeom>
-          <a:noFill/>
-          <a:ln/>
-        </p:spPr>
-        <p:txBody>
-          <a:bodyPr wrap="square" lIns="0" tIns="0" rIns="0" bIns="0" rtlCol="0" anchor="t"/>
-          <a:lstStyle/>
-          <a:p>
-            <a:pPr algn="l" indent="0" marL="0">
-              <a:buNone/>
-            </a:pPr>
-            <a:r>
-              <a:rPr lang="en-US" sz="3000" b="1" dirty="0">
-                <a:solidFill>
-                  <a:srgbClr val="2E5EAA"/>
-                </a:solidFill>
-                <a:latin typeface="Calibri" pitchFamily="34" charset="0"/>
-                <a:ea typeface="Calibri" pitchFamily="34" charset="-122"/>
-                <a:cs typeface="Calibri" pitchFamily="34" charset="-120"/>
-              </a:rPr>
-              <a:t>5 min</a:t>
-            </a:r>
-            <a:endParaRPr lang="en-US" sz="3000" dirty="0"/>
-          </a:p>
-        </p:txBody>
-      </p:sp>
-      <p:sp>
-        <p:nvSpPr>
-          <p:cNvPr id="12" name="anim:2:253"/>
+          <p:cNvPr id="11" name="anim:2:252"/>
           <p:cNvSpPr/>
           <p:nvPr/>
         </p:nvSpPr>
         <p:spPr>
           <a:xfrm>
             <a:off x="3360420" y="1600200"/>
-            <a:ext cx="2651760" cy="4251960"/>
+            <a:ext cx="2651760" cy="4389120"/>
           </a:xfrm>
           <a:prstGeom prst="roundRect">
             <a:avLst>
@@ -16478,7 +16439,7 @@
       </p:sp>
       <p:sp>
         <p:nvSpPr>
-          <p:cNvPr id="13" name="anim:2:254"/>
+          <p:cNvPr id="12" name="anim:2:253"/>
           <p:cNvSpPr/>
           <p:nvPr/>
         </p:nvSpPr>
@@ -16503,7 +16464,7 @@
       </p:sp>
       <p:sp>
         <p:nvSpPr>
-          <p:cNvPr id="14" name="anim:2:255"/>
+          <p:cNvPr id="13" name="anim:2:254"/>
           <p:cNvSpPr txBox="1"/>
           <p:nvPr/>
         </p:nvSpPr>
@@ -16542,7 +16503,7 @@
       </p:sp>
       <p:sp>
         <p:nvSpPr>
-          <p:cNvPr id="15" name="anim:2:256"/>
+          <p:cNvPr id="14" name="anim:2:255"/>
           <p:cNvSpPr txBox="1"/>
           <p:nvPr/>
         </p:nvSpPr>
@@ -16581,7 +16542,7 @@
       </p:sp>
       <p:sp>
         <p:nvSpPr>
-          <p:cNvPr id="16" name="anim:2:257"/>
+          <p:cNvPr id="15" name="anim:2:256"/>
           <p:cNvSpPr txBox="1"/>
           <p:nvPr/>
         </p:nvSpPr>
@@ -16620,14 +16581,14 @@
       </p:sp>
       <p:sp>
         <p:nvSpPr>
-          <p:cNvPr id="17" name="anim:2:258"/>
+          <p:cNvPr id="16" name="anim:2:257"/>
           <p:cNvSpPr txBox="1"/>
           <p:nvPr/>
         </p:nvSpPr>
         <p:spPr>
           <a:xfrm>
-            <a:off x="3589020" y="3566160"/>
-            <a:ext cx="2240280" cy="1463040"/>
+            <a:off x="3589020" y="3611880"/>
+            <a:ext cx="2240280" cy="2194560"/>
           </a:xfrm>
           <a:prstGeom prst="rect">
             <a:avLst/>
@@ -16643,7 +16604,7 @@
               <a:buNone/>
             </a:pPr>
             <a:r>
-              <a:rPr lang="en-US" sz="1400" dirty="0">
+              <a:rPr lang="en-US" sz="1600" dirty="0">
                 <a:solidFill>
                   <a:srgbClr val="1F2937"/>
                 </a:solidFill>
@@ -16653,59 +16614,20 @@
               </a:rPr>
               <a:t>Fontes de dados, integração, problemas nos dados, grão e aditividade e a estrela Matrícula.</a:t>
             </a:r>
-            <a:endParaRPr lang="en-US" sz="1400" dirty="0"/>
+            <a:endParaRPr lang="en-US" sz="1600" dirty="0"/>
           </a:p>
         </p:txBody>
       </p:sp>
       <p:sp>
         <p:nvSpPr>
-          <p:cNvPr id="18" name="anim:2:259"/>
-          <p:cNvSpPr txBox="1"/>
-          <p:nvPr/>
-        </p:nvSpPr>
-        <p:spPr>
-          <a:xfrm>
-            <a:off x="3589020" y="5074920"/>
-            <a:ext cx="2240280" cy="594360"/>
-          </a:xfrm>
-          <a:prstGeom prst="rect">
-            <a:avLst/>
-          </a:prstGeom>
-          <a:noFill/>
-          <a:ln/>
-        </p:spPr>
-        <p:txBody>
-          <a:bodyPr wrap="square" lIns="0" tIns="0" rIns="0" bIns="0" rtlCol="0" anchor="t"/>
-          <a:lstStyle/>
-          <a:p>
-            <a:pPr algn="l" indent="0" marL="0">
-              <a:buNone/>
-            </a:pPr>
-            <a:r>
-              <a:rPr lang="en-US" sz="3000" b="1" dirty="0">
-                <a:solidFill>
-                  <a:srgbClr val="2E5EAA"/>
-                </a:solidFill>
-                <a:latin typeface="Calibri" pitchFamily="34" charset="0"/>
-                <a:ea typeface="Calibri" pitchFamily="34" charset="-122"/>
-                <a:cs typeface="Calibri" pitchFamily="34" charset="-120"/>
-              </a:rPr>
-              <a:t>5 min</a:t>
-            </a:r>
-            <a:endParaRPr lang="en-US" sz="3000" dirty="0"/>
-          </a:p>
-        </p:txBody>
-      </p:sp>
-      <p:sp>
-        <p:nvSpPr>
-          <p:cNvPr id="19" name="anim:3:260"/>
+          <p:cNvPr id="17" name="anim:3:258"/>
           <p:cNvSpPr/>
           <p:nvPr/>
         </p:nvSpPr>
         <p:spPr>
           <a:xfrm>
             <a:off x="6172200" y="1600200"/>
-            <a:ext cx="2651760" cy="4251960"/>
+            <a:ext cx="2651760" cy="4389120"/>
           </a:xfrm>
           <a:prstGeom prst="roundRect">
             <a:avLst>
@@ -16732,7 +16654,7 @@
       </p:sp>
       <p:sp>
         <p:nvSpPr>
-          <p:cNvPr id="20" name="anim:3:261"/>
+          <p:cNvPr id="18" name="anim:3:259"/>
           <p:cNvSpPr/>
           <p:nvPr/>
         </p:nvSpPr>
@@ -16757,7 +16679,7 @@
       </p:sp>
       <p:sp>
         <p:nvSpPr>
-          <p:cNvPr id="21" name="anim:3:262"/>
+          <p:cNvPr id="19" name="anim:3:260"/>
           <p:cNvSpPr txBox="1"/>
           <p:nvPr/>
         </p:nvSpPr>
@@ -16796,7 +16718,7 @@
       </p:sp>
       <p:sp>
         <p:nvSpPr>
-          <p:cNvPr id="22" name="anim:3:263"/>
+          <p:cNvPr id="20" name="anim:3:261"/>
           <p:cNvSpPr txBox="1"/>
           <p:nvPr/>
         </p:nvSpPr>
@@ -16835,7 +16757,7 @@
       </p:sp>
       <p:sp>
         <p:nvSpPr>
-          <p:cNvPr id="23" name="anim:3:264"/>
+          <p:cNvPr id="21" name="anim:3:262"/>
           <p:cNvSpPr txBox="1"/>
           <p:nvPr/>
         </p:nvSpPr>
@@ -16874,14 +16796,14 @@
       </p:sp>
       <p:sp>
         <p:nvSpPr>
-          <p:cNvPr id="24" name="anim:3:265"/>
+          <p:cNvPr id="22" name="anim:3:263"/>
           <p:cNvSpPr txBox="1"/>
           <p:nvPr/>
         </p:nvSpPr>
         <p:spPr>
           <a:xfrm>
-            <a:off x="6400800" y="3566160"/>
-            <a:ext cx="2240280" cy="1463040"/>
+            <a:off x="6400800" y="3611880"/>
+            <a:ext cx="2240280" cy="2194560"/>
           </a:xfrm>
           <a:prstGeom prst="rect">
             <a:avLst/>
@@ -16897,7 +16819,7 @@
               <a:buNone/>
             </a:pPr>
             <a:r>
-              <a:rPr lang="en-US" sz="1400" dirty="0">
+              <a:rPr lang="en-US" sz="1600" dirty="0">
                 <a:solidFill>
                   <a:srgbClr val="1F2937"/>
                 </a:solidFill>
@@ -16907,59 +16829,20 @@
               </a:rPr>
               <a:t>Estrelas Fila, Desfecho, Ocupação de Turma e População; constelação de fatos.</a:t>
             </a:r>
-            <a:endParaRPr lang="en-US" sz="1400" dirty="0"/>
+            <a:endParaRPr lang="en-US" sz="1600" dirty="0"/>
           </a:p>
         </p:txBody>
       </p:sp>
       <p:sp>
         <p:nvSpPr>
-          <p:cNvPr id="25" name="anim:3:266"/>
-          <p:cNvSpPr txBox="1"/>
-          <p:nvPr/>
-        </p:nvSpPr>
-        <p:spPr>
-          <a:xfrm>
-            <a:off x="6400800" y="5074920"/>
-            <a:ext cx="2240280" cy="594360"/>
-          </a:xfrm>
-          <a:prstGeom prst="rect">
-            <a:avLst/>
-          </a:prstGeom>
-          <a:noFill/>
-          <a:ln/>
-        </p:spPr>
-        <p:txBody>
-          <a:bodyPr wrap="square" lIns="0" tIns="0" rIns="0" bIns="0" rtlCol="0" anchor="t"/>
-          <a:lstStyle/>
-          <a:p>
-            <a:pPr algn="l" indent="0" marL="0">
-              <a:buNone/>
-            </a:pPr>
-            <a:r>
-              <a:rPr lang="en-US" sz="3000" b="1" dirty="0">
-                <a:solidFill>
-                  <a:srgbClr val="2E5EAA"/>
-                </a:solidFill>
-                <a:latin typeface="Calibri" pitchFamily="34" charset="0"/>
-                <a:ea typeface="Calibri" pitchFamily="34" charset="-122"/>
-                <a:cs typeface="Calibri" pitchFamily="34" charset="-120"/>
-              </a:rPr>
-              <a:t>5 min</a:t>
-            </a:r>
-            <a:endParaRPr lang="en-US" sz="3000" dirty="0"/>
-          </a:p>
-        </p:txBody>
-      </p:sp>
-      <p:sp>
-        <p:nvSpPr>
-          <p:cNvPr id="26" name="anim:4:267"/>
+          <p:cNvPr id="23" name="anim:4:264"/>
           <p:cNvSpPr/>
           <p:nvPr/>
         </p:nvSpPr>
         <p:spPr>
           <a:xfrm>
             <a:off x="8983980" y="1600200"/>
-            <a:ext cx="2651760" cy="4251960"/>
+            <a:ext cx="2651760" cy="4389120"/>
           </a:xfrm>
           <a:prstGeom prst="roundRect">
             <a:avLst>
@@ -16986,7 +16869,7 @@
       </p:sp>
       <p:sp>
         <p:nvSpPr>
-          <p:cNvPr id="27" name="anim:4:268"/>
+          <p:cNvPr id="24" name="anim:4:265"/>
           <p:cNvSpPr/>
           <p:nvPr/>
         </p:nvSpPr>
@@ -17011,7 +16894,7 @@
       </p:sp>
       <p:sp>
         <p:nvSpPr>
-          <p:cNvPr id="28" name="anim:4:269"/>
+          <p:cNvPr id="25" name="anim:4:266"/>
           <p:cNvSpPr txBox="1"/>
           <p:nvPr/>
         </p:nvSpPr>
@@ -17050,7 +16933,7 @@
       </p:sp>
       <p:sp>
         <p:nvSpPr>
-          <p:cNvPr id="29" name="anim:4:270"/>
+          <p:cNvPr id="26" name="anim:4:267"/>
           <p:cNvSpPr txBox="1"/>
           <p:nvPr/>
         </p:nvSpPr>
@@ -17089,7 +16972,7 @@
       </p:sp>
       <p:sp>
         <p:nvSpPr>
-          <p:cNvPr id="30" name="anim:4:271"/>
+          <p:cNvPr id="27" name="anim:4:268"/>
           <p:cNvSpPr txBox="1"/>
           <p:nvPr/>
         </p:nvSpPr>
@@ -17128,14 +17011,14 @@
       </p:sp>
       <p:sp>
         <p:nvSpPr>
-          <p:cNvPr id="31" name="anim:4:272"/>
+          <p:cNvPr id="28" name="anim:4:269"/>
           <p:cNvSpPr txBox="1"/>
           <p:nvPr/>
         </p:nvSpPr>
         <p:spPr>
           <a:xfrm>
-            <a:off x="9212580" y="3566160"/>
-            <a:ext cx="2240280" cy="1463040"/>
+            <a:off x="9212580" y="3611880"/>
+            <a:ext cx="2240280" cy="2194560"/>
           </a:xfrm>
           <a:prstGeom prst="rect">
             <a:avLst/>
@@ -17151,7 +17034,7 @@
               <a:buNone/>
             </a:pPr>
             <a:r>
-              <a:rPr lang="en-US" sz="1400" dirty="0">
+              <a:rPr lang="en-US" sz="1600" dirty="0">
                 <a:solidFill>
                   <a:srgbClr val="1F2937"/>
                 </a:solidFill>
@@ -17161,85 +17044,7 @@
               </a:rPr>
               <a:t>Consultas OLAP, resultados com os dados reais e decisões de projeto.</a:t>
             </a:r>
-            <a:endParaRPr lang="en-US" sz="1400" dirty="0"/>
-          </a:p>
-        </p:txBody>
-      </p:sp>
-      <p:sp>
-        <p:nvSpPr>
-          <p:cNvPr id="32" name="anim:4:273"/>
-          <p:cNvSpPr txBox="1"/>
-          <p:nvPr/>
-        </p:nvSpPr>
-        <p:spPr>
-          <a:xfrm>
-            <a:off x="9212580" y="5074920"/>
-            <a:ext cx="2240280" cy="594360"/>
-          </a:xfrm>
-          <a:prstGeom prst="rect">
-            <a:avLst/>
-          </a:prstGeom>
-          <a:noFill/>
-          <a:ln/>
-        </p:spPr>
-        <p:txBody>
-          <a:bodyPr wrap="square" lIns="0" tIns="0" rIns="0" bIns="0" rtlCol="0" anchor="t"/>
-          <a:lstStyle/>
-          <a:p>
-            <a:pPr algn="l" indent="0" marL="0">
-              <a:buNone/>
-            </a:pPr>
-            <a:r>
-              <a:rPr lang="en-US" sz="3000" b="1" dirty="0">
-                <a:solidFill>
-                  <a:srgbClr val="2E5EAA"/>
-                </a:solidFill>
-                <a:latin typeface="Calibri" pitchFamily="34" charset="0"/>
-                <a:ea typeface="Calibri" pitchFamily="34" charset="-122"/>
-                <a:cs typeface="Calibri" pitchFamily="34" charset="-120"/>
-              </a:rPr>
-              <a:t>5 min</a:t>
-            </a:r>
-            <a:endParaRPr lang="en-US" sz="3000" dirty="0"/>
-          </a:p>
-        </p:txBody>
-      </p:sp>
-      <p:sp>
-        <p:nvSpPr>
-          <p:cNvPr id="33" name="anim:5:274"/>
-          <p:cNvSpPr txBox="1"/>
-          <p:nvPr/>
-        </p:nvSpPr>
-        <p:spPr>
-          <a:xfrm>
-            <a:off x="548640" y="5989320"/>
-            <a:ext cx="11064240" cy="292608"/>
-          </a:xfrm>
-          <a:prstGeom prst="rect">
-            <a:avLst/>
-          </a:prstGeom>
-          <a:noFill/>
-          <a:ln/>
-        </p:spPr>
-        <p:txBody>
-          <a:bodyPr wrap="square" lIns="0" tIns="0" rIns="0" bIns="0" rtlCol="0" anchor="t"/>
-          <a:lstStyle/>
-          <a:p>
-            <a:pPr algn="l" indent="0" marL="0">
-              <a:buNone/>
-            </a:pPr>
-            <a:r>
-              <a:rPr lang="en-US" sz="1200" i="1" dirty="0">
-                <a:solidFill>
-                  <a:srgbClr val="566175"/>
-                </a:solidFill>
-                <a:latin typeface="Calibri" pitchFamily="34" charset="0"/>
-                <a:ea typeface="Calibri" pitchFamily="34" charset="-122"/>
-                <a:cs typeface="Calibri" pitchFamily="34" charset="-120"/>
-              </a:rPr>
-              <a:t>Total previsto: 20 minutos, sem contar as perguntas. Com outro limite de tempo, a divisão continua em quatro partes iguais.</a:t>
-            </a:r>
-            <a:endParaRPr lang="en-US" sz="1200" dirty="0"/>
+            <a:endParaRPr lang="en-US" sz="1600" dirty="0"/>
           </a:p>
         </p:txBody>
       </p:sp>
@@ -17583,7 +17388,7 @@
                         <p:par>
                           <p:cTn id="28" fill="hold">
                             <p:stCondLst>
-                              <p:cond delay="0"/>
+                              <p:cond delay="250"/>
                             </p:stCondLst>
                             <p:childTnLst>
                               <p:par>
@@ -17847,7 +17652,7 @@
                         <p:par>
                           <p:cTn id="52" fill="hold">
                             <p:stCondLst>
-                              <p:cond delay="250"/>
+                              <p:cond delay="500"/>
                             </p:stCondLst>
                             <p:childTnLst>
                               <p:par>
@@ -17891,7 +17696,7 @@
                         <p:par>
                           <p:cTn id="56" fill="hold">
                             <p:stCondLst>
-                              <p:cond delay="250"/>
+                              <p:cond delay="500"/>
                             </p:stCondLst>
                             <p:childTnLst>
                               <p:par>
@@ -18111,7 +17916,7 @@
                         <p:par>
                           <p:cTn id="76" fill="hold">
                             <p:stCondLst>
-                              <p:cond delay="500"/>
+                              <p:cond delay="750"/>
                             </p:stCondLst>
                             <p:childTnLst>
                               <p:par>
@@ -18155,7 +17960,7 @@
                         <p:par>
                           <p:cTn id="80" fill="hold">
                             <p:stCondLst>
-                              <p:cond delay="500"/>
+                              <p:cond delay="750"/>
                             </p:stCondLst>
                             <p:childTnLst>
                               <p:par>
@@ -18199,7 +18004,7 @@
                         <p:par>
                           <p:cTn id="84" fill="hold">
                             <p:stCondLst>
-                              <p:cond delay="500"/>
+                              <p:cond delay="750"/>
                             </p:stCondLst>
                             <p:childTnLst>
                               <p:par>
@@ -18363,226 +18168,6 @@
                                         <p:cTn id="99" dur="400"/>
                                         <p:tgtEl>
                                           <p:spTgt spid="28"/>
-                                        </p:tgtEl>
-                                      </p:cBhvr>
-                                    </p:animEffect>
-                                  </p:childTnLst>
-                                </p:cTn>
-                              </p:par>
-                            </p:childTnLst>
-                          </p:cTn>
-                        </p:par>
-                        <p:par>
-                          <p:cTn id="100" fill="hold">
-                            <p:stCondLst>
-                              <p:cond delay="750"/>
-                            </p:stCondLst>
-                            <p:childTnLst>
-                              <p:par>
-                                <p:cTn id="101" presetID="10" presetClass="entr" presetSubtype="0" fill="hold" grpId="0" nodeType="withEffect">
-                                  <p:stCondLst>
-                                    <p:cond delay="0"/>
-                                  </p:stCondLst>
-                                  <p:childTnLst>
-                                    <p:set>
-                                      <p:cBhvr>
-                                        <p:cTn id="102" dur="1" fill="hold">
-                                          <p:stCondLst>
-                                            <p:cond delay="0"/>
-                                          </p:stCondLst>
-                                        </p:cTn>
-                                        <p:tgtEl>
-                                          <p:spTgt spid="29"/>
-                                        </p:tgtEl>
-                                        <p:attrNameLst>
-                                          <p:attrName>style.visibility</p:attrName>
-                                        </p:attrNameLst>
-                                      </p:cBhvr>
-                                      <p:to>
-                                        <p:strVal val="visible"/>
-                                      </p:to>
-                                    </p:set>
-                                    <p:animEffect transition="in" filter="fade">
-                                      <p:cBhvr>
-                                        <p:cTn id="103" dur="400"/>
-                                        <p:tgtEl>
-                                          <p:spTgt spid="29"/>
-                                        </p:tgtEl>
-                                      </p:cBhvr>
-                                    </p:animEffect>
-                                  </p:childTnLst>
-                                </p:cTn>
-                              </p:par>
-                            </p:childTnLst>
-                          </p:cTn>
-                        </p:par>
-                        <p:par>
-                          <p:cTn id="104" fill="hold">
-                            <p:stCondLst>
-                              <p:cond delay="750"/>
-                            </p:stCondLst>
-                            <p:childTnLst>
-                              <p:par>
-                                <p:cTn id="105" presetID="10" presetClass="entr" presetSubtype="0" fill="hold" grpId="0" nodeType="withEffect">
-                                  <p:stCondLst>
-                                    <p:cond delay="0"/>
-                                  </p:stCondLst>
-                                  <p:childTnLst>
-                                    <p:set>
-                                      <p:cBhvr>
-                                        <p:cTn id="106" dur="1" fill="hold">
-                                          <p:stCondLst>
-                                            <p:cond delay="0"/>
-                                          </p:stCondLst>
-                                        </p:cTn>
-                                        <p:tgtEl>
-                                          <p:spTgt spid="30"/>
-                                        </p:tgtEl>
-                                        <p:attrNameLst>
-                                          <p:attrName>style.visibility</p:attrName>
-                                        </p:attrNameLst>
-                                      </p:cBhvr>
-                                      <p:to>
-                                        <p:strVal val="visible"/>
-                                      </p:to>
-                                    </p:set>
-                                    <p:animEffect transition="in" filter="fade">
-                                      <p:cBhvr>
-                                        <p:cTn id="107" dur="400"/>
-                                        <p:tgtEl>
-                                          <p:spTgt spid="30"/>
-                                        </p:tgtEl>
-                                      </p:cBhvr>
-                                    </p:animEffect>
-                                  </p:childTnLst>
-                                </p:cTn>
-                              </p:par>
-                            </p:childTnLst>
-                          </p:cTn>
-                        </p:par>
-                        <p:par>
-                          <p:cTn id="108" fill="hold">
-                            <p:stCondLst>
-                              <p:cond delay="750"/>
-                            </p:stCondLst>
-                            <p:childTnLst>
-                              <p:par>
-                                <p:cTn id="109" presetID="10" presetClass="entr" presetSubtype="0" fill="hold" grpId="0" nodeType="withEffect">
-                                  <p:stCondLst>
-                                    <p:cond delay="0"/>
-                                  </p:stCondLst>
-                                  <p:childTnLst>
-                                    <p:set>
-                                      <p:cBhvr>
-                                        <p:cTn id="110" dur="1" fill="hold">
-                                          <p:stCondLst>
-                                            <p:cond delay="0"/>
-                                          </p:stCondLst>
-                                        </p:cTn>
-                                        <p:tgtEl>
-                                          <p:spTgt spid="31"/>
-                                        </p:tgtEl>
-                                        <p:attrNameLst>
-                                          <p:attrName>style.visibility</p:attrName>
-                                        </p:attrNameLst>
-                                      </p:cBhvr>
-                                      <p:to>
-                                        <p:strVal val="visible"/>
-                                      </p:to>
-                                    </p:set>
-                                    <p:animEffect transition="in" filter="fade">
-                                      <p:cBhvr>
-                                        <p:cTn id="111" dur="400"/>
-                                        <p:tgtEl>
-                                          <p:spTgt spid="31"/>
-                                        </p:tgtEl>
-                                      </p:cBhvr>
-                                    </p:animEffect>
-                                  </p:childTnLst>
-                                </p:cTn>
-                              </p:par>
-                            </p:childTnLst>
-                          </p:cTn>
-                        </p:par>
-                        <p:par>
-                          <p:cTn id="112" fill="hold">
-                            <p:stCondLst>
-                              <p:cond delay="750"/>
-                            </p:stCondLst>
-                            <p:childTnLst>
-                              <p:par>
-                                <p:cTn id="113" presetID="10" presetClass="entr" presetSubtype="0" fill="hold" grpId="0" nodeType="withEffect">
-                                  <p:stCondLst>
-                                    <p:cond delay="0"/>
-                                  </p:stCondLst>
-                                  <p:childTnLst>
-                                    <p:set>
-                                      <p:cBhvr>
-                                        <p:cTn id="114" dur="1" fill="hold">
-                                          <p:stCondLst>
-                                            <p:cond delay="0"/>
-                                          </p:stCondLst>
-                                        </p:cTn>
-                                        <p:tgtEl>
-                                          <p:spTgt spid="32"/>
-                                        </p:tgtEl>
-                                        <p:attrNameLst>
-                                          <p:attrName>style.visibility</p:attrName>
-                                        </p:attrNameLst>
-                                      </p:cBhvr>
-                                      <p:to>
-                                        <p:strVal val="visible"/>
-                                      </p:to>
-                                    </p:set>
-                                    <p:animEffect transition="in" filter="fade">
-                                      <p:cBhvr>
-                                        <p:cTn id="115" dur="400"/>
-                                        <p:tgtEl>
-                                          <p:spTgt spid="32"/>
-                                        </p:tgtEl>
-                                      </p:cBhvr>
-                                    </p:animEffect>
-                                  </p:childTnLst>
-                                </p:cTn>
-                              </p:par>
-                            </p:childTnLst>
-                          </p:cTn>
-                        </p:par>
-                        <p:par>
-                          <p:cTn id="116" fill="hold">
-                            <p:stCondLst>
-                              <p:cond delay="1000"/>
-                            </p:stCondLst>
-                            <p:childTnLst>
-                              <p:par>
-                                <p:cTn id="117" presetID="10" presetClass="entr" presetSubtype="0" fill="hold" grpId="0" nodeType="withEffect">
-                                  <p:stCondLst>
-                                    <p:cond delay="0"/>
-                                  </p:stCondLst>
-                                  <p:childTnLst>
-                                    <p:set>
-                                      <p:cBhvr>
-                                        <p:cTn id="118" dur="1" fill="hold">
-                                          <p:stCondLst>
-                                            <p:cond delay="0"/>
-                                          </p:stCondLst>
-                                        </p:cTn>
-                                        <p:tgtEl>
-                                          <p:spTgt spid="33"/>
-                                        </p:tgtEl>
-                                        <p:attrNameLst>
-                                          <p:attrName>style.visibility</p:attrName>
-                                        </p:attrNameLst>
-                                      </p:cBhvr>
-                                      <p:to>
-                                        <p:strVal val="visible"/>
-                                      </p:to>
-                                    </p:set>
-                                    <p:animEffect transition="in" filter="fade">
-                                      <p:cBhvr>
-                                        <p:cTn id="119" dur="400"/>
-                                        <p:tgtEl>
-                                          <p:spTgt spid="33"/>
                                         </p:tgtEl>
                                       </p:cBhvr>
                                     </p:animEffect>
@@ -18641,11 +18226,6 @@
       <p:bldP spid="26" grpId="0" animBg="1"/>
       <p:bldP spid="27" grpId="0" animBg="1"/>
       <p:bldP spid="28" grpId="0" animBg="1"/>
-      <p:bldP spid="29" grpId="0" animBg="1"/>
-      <p:bldP spid="30" grpId="0" animBg="1"/>
-      <p:bldP spid="31" grpId="0" animBg="1"/>
-      <p:bldP spid="32" grpId="0" animBg="1"/>
-      <p:bldP spid="33" grpId="0" animBg="1"/>
     </p:bldLst>
   </p:timing>
 </p:sld>

</xml_diff>